<commit_message>
slide 21: o link do repositório
Agora que ele existe. Sem https:// porque o deck abre offline e o montar.sh
recusa link externo.

Co-Authored-By: Claude Fable 5.1 <noreply@anthropic.com>
</commit_message>
<xml_diff>
--- a/apresentacao/aula.pptx
+++ b/apresentacao/aula.pptx
@@ -1666,7 +1666,7 @@
           <a:p>
             <a:r>
               <a:rPr lang="en-US" dirty="0"/>
-              <a:t>Fecho curto. O repositório sobe em dois comandos. Quando o link público existir, ponha aqui. Depois abra para as perguntas: são 10 minutos.</a:t>
+              <a:t>Fecho curto. O repositório sobe em dois comandos e o link está na tela. Depois abra para as perguntas: são 10 minutos.</a:t>
             </a:r>
             <a:endParaRPr lang="en-US" dirty="0"/>
           </a:p>
@@ -15161,6 +15161,45 @@
           </a:p>
         </p:txBody>
       </p:sp>
+      <p:sp>
+        <p:nvSpPr>
+          <p:cNvPr id="15" name="Text 12"/>
+          <p:cNvSpPr txBox="1"/>
+          <p:nvPr/>
+        </p:nvSpPr>
+        <p:spPr>
+          <a:xfrm>
+            <a:off x="548640" y="5623560"/>
+            <a:ext cx="8229600" cy="320040"/>
+          </a:xfrm>
+          <a:prstGeom prst="rect">
+            <a:avLst/>
+          </a:prstGeom>
+          <a:noFill/>
+          <a:ln/>
+        </p:spPr>
+        <p:txBody>
+          <a:bodyPr wrap="square" lIns="0" tIns="0" rIns="0" bIns="0" rtlCol="0" anchor="ctr"/>
+          <a:lstStyle/>
+          <a:p>
+            <a:pPr indent="0" marL="0">
+              <a:buNone/>
+            </a:pPr>
+            <a:r>
+              <a:rPr lang="en-US" sz="1300" dirty="0">
+                <a:solidFill>
+                  <a:srgbClr val="FF8A4C"/>
+                </a:solidFill>
+                <a:latin typeface="Courier New" pitchFamily="34" charset="0"/>
+                <a:ea typeface="Courier New" pitchFamily="34" charset="-122"/>
+                <a:cs typeface="Courier New" pitchFamily="34" charset="-120"/>
+              </a:rPr>
+              <a:t>github.com/italovinicius18/semuni-2026-engenharia-de-dados</a:t>
+            </a:r>
+            <a:endParaRPr lang="en-US" sz="1300" dirty="0"/>
+          </a:p>
+        </p:txBody>
+      </p:sp>
     </p:spTree>
   </p:cSld>
   <p:clrMapOvr>

</xml_diff>

<commit_message>
demo: consultas sem crase e com decimal
A shell comia as crases de delta.`s3a://lake/bronze` e o Spark recebia
"delta.\ WHERE". O consulta.py ja registra as views bronze, silver,
fornecedores e fornecedores_total, entao a consulta usa o nome. E a soma
na bronze saia como 1.64E7 na tela; CAST AS DECIMAL(18,2) resolve, e e o
mesmo remedio que a gold ja usa.

Co-Authored-By: Claude Fable 5.1 <noreply@anthropic.com>
</commit_message>
<xml_diff>
--- a/apresentacao/aula.pptx
+++ b/apresentacao/aula.pptx
@@ -8425,7 +8425,7 @@
                 <a:ea typeface="Courier New" pitchFamily="34" charset="-122"/>
                 <a:cs typeface="Courier New" pitchFamily="34" charset="-120"/>
               </a:rPr>
-              <a:t> SELECT txtFornecedor, sum(vlrDocumento) t</a:t>
+              <a:t> SELECT txtFornecedor, CAST(sum(vlrDocumento) AS DECIMAL(18,2)) t</a:t>
             </a:r>
             <a:endParaRPr lang="en-US" sz="1250" dirty="0"/>
           </a:p>
@@ -8445,7 +8445,7 @@
                 <a:ea typeface="Courier New" pitchFamily="34" charset="-122"/>
                 <a:cs typeface="Courier New" pitchFamily="34" charset="-120"/>
               </a:rPr>
-              <a:t>           FROM delta.`s3a://lake/</a:t>
+              <a:t>           FROM </a:t>
             </a:r>
             <a:pPr indent="0" marL="0">
               <a:lnSpc>
@@ -8479,7 +8479,7 @@
                 <a:ea typeface="Courier New" pitchFamily="34" charset="-122"/>
                 <a:cs typeface="Courier New" pitchFamily="34" charset="-120"/>
               </a:rPr>
-              <a:t>` WHERE numAno=2025 GROUP BY 1 ORDER BY 2 DESC LIMIT 3;</a:t>
+              <a:t> WHERE numAno=2025 GROUP BY 1 ORDER BY 2 DESC LIMIT 3;</a:t>
             </a:r>
             <a:endParaRPr lang="en-US" sz="1250" dirty="0"/>
           </a:p>
@@ -8714,7 +8714,7 @@
                 <a:ea typeface="Calibri" pitchFamily="34" charset="-122"/>
                 <a:cs typeface="Calibri" pitchFamily="34" charset="-120"/>
               </a:rPr>
-              <a:t>a mesma pergunta do slide 5, escrita como consulta. Quem lê não precisa abrir o script para saber o que foi perguntado.</a:t>
+              <a:t>a mesma pergunta do slide 5, escrita como consulta. bronze é a tabela do slide 12, registrada pelo nome. Quem lê não precisa abrir o script para saber o que foi perguntado.</a:t>
             </a:r>
             <a:endParaRPr lang="en-US" sz="1000" dirty="0"/>
           </a:p>

</xml_diff>